<commit_message>
ajout des resultats à la présentation
</commit_message>
<xml_diff>
--- a/Présentation.pptx
+++ b/Présentation.pptx
@@ -9435,6 +9435,36 @@
           </a:p>
         </p:txBody>
       </p:sp>
+      <p:pic>
+        <p:nvPicPr>
+          <p:cNvPr id="4" name="Image 3">
+            <a:extLst>
+              <a:ext uri="{FF2B5EF4-FFF2-40B4-BE49-F238E27FC236}">
+                <a16:creationId xmlns:a16="http://schemas.microsoft.com/office/drawing/2014/main" id="{7A8D9EB4-F010-558D-B6B7-E96AA51A3424}"/>
+              </a:ext>
+            </a:extLst>
+          </p:cNvPr>
+          <p:cNvPicPr>
+            <a:picLocks noChangeAspect="1"/>
+          </p:cNvPicPr>
+          <p:nvPr/>
+        </p:nvPicPr>
+        <p:blipFill>
+          <a:blip r:embed="rId2"/>
+          <a:stretch>
+            <a:fillRect/>
+          </a:stretch>
+        </p:blipFill>
+        <p:spPr>
+          <a:xfrm>
+            <a:off x="749787" y="2232839"/>
+            <a:ext cx="10944256" cy="1798848"/>
+          </a:xfrm>
+          <a:prstGeom prst="rect">
+            <a:avLst/>
+          </a:prstGeom>
+        </p:spPr>
+      </p:pic>
     </p:spTree>
     <p:extLst>
       <p:ext uri="{BB962C8B-B14F-4D97-AF65-F5344CB8AC3E}">

</xml_diff>

<commit_message>
MaJ de la présentation
</commit_message>
<xml_diff>
--- a/Présentation.pptx
+++ b/Présentation.pptx
@@ -5,7 +5,7 @@
     <p:sldMasterId id="2147483648" r:id="rId1"/>
   </p:sldMasterIdLst>
   <p:notesMasterIdLst>
-    <p:notesMasterId r:id="rId32"/>
+    <p:notesMasterId r:id="rId31"/>
   </p:notesMasterIdLst>
   <p:sldIdLst>
     <p:sldId id="259" r:id="rId2"/>
@@ -27,17 +27,16 @@
     <p:sldId id="273" r:id="rId18"/>
     <p:sldId id="275" r:id="rId19"/>
     <p:sldId id="279" r:id="rId20"/>
-    <p:sldId id="277" r:id="rId21"/>
-    <p:sldId id="283" r:id="rId22"/>
-    <p:sldId id="284" r:id="rId23"/>
-    <p:sldId id="281" r:id="rId24"/>
-    <p:sldId id="282" r:id="rId25"/>
-    <p:sldId id="285" r:id="rId26"/>
-    <p:sldId id="286" r:id="rId27"/>
-    <p:sldId id="287" r:id="rId28"/>
-    <p:sldId id="288" r:id="rId29"/>
-    <p:sldId id="276" r:id="rId30"/>
-    <p:sldId id="290" r:id="rId31"/>
+    <p:sldId id="283" r:id="rId21"/>
+    <p:sldId id="284" r:id="rId22"/>
+    <p:sldId id="281" r:id="rId23"/>
+    <p:sldId id="282" r:id="rId24"/>
+    <p:sldId id="285" r:id="rId25"/>
+    <p:sldId id="286" r:id="rId26"/>
+    <p:sldId id="287" r:id="rId27"/>
+    <p:sldId id="288" r:id="rId28"/>
+    <p:sldId id="276" r:id="rId29"/>
+    <p:sldId id="290" r:id="rId30"/>
   </p:sldIdLst>
   <p:sldSz cx="12192000" cy="6858000"/>
   <p:notesSz cx="6858000" cy="9144000"/>
@@ -226,7 +225,7 @@
           <a:p>
             <a:fld id="{707E1AE0-F169-4B04-AC31-32DDA66614B2}" type="datetimeFigureOut">
               <a:rPr lang="fr-FR" smtClean="0"/>
-              <a:t>25/08/2026</a:t>
+              <a:t>27/08/2026</a:t>
             </a:fld>
             <a:endParaRPr lang="fr-FR"/>
           </a:p>
@@ -1267,7 +1266,7 @@
           <a:p>
             <a:fld id="{4734364E-57BD-44F2-A53B-320C3BD2F0CA}" type="slidenum">
               <a:rPr lang="fr-FR" smtClean="0"/>
-              <a:t>22</a:t>
+              <a:t>21</a:t>
             </a:fld>
             <a:endParaRPr lang="fr-FR"/>
           </a:p>
@@ -1351,7 +1350,7 @@
           <a:p>
             <a:fld id="{4734364E-57BD-44F2-A53B-320C3BD2F0CA}" type="slidenum">
               <a:rPr lang="fr-FR" smtClean="0"/>
-              <a:t>24</a:t>
+              <a:t>23</a:t>
             </a:fld>
             <a:endParaRPr lang="fr-FR"/>
           </a:p>
@@ -1438,7 +1437,7 @@
           <a:p>
             <a:fld id="{4734364E-57BD-44F2-A53B-320C3BD2F0CA}" type="slidenum">
               <a:rPr lang="fr-FR" smtClean="0"/>
-              <a:t>27</a:t>
+              <a:t>26</a:t>
             </a:fld>
             <a:endParaRPr lang="fr-FR"/>
           </a:p>
@@ -1522,7 +1521,7 @@
           <a:p>
             <a:fld id="{4734364E-57BD-44F2-A53B-320C3BD2F0CA}" type="slidenum">
               <a:rPr lang="fr-FR" smtClean="0"/>
-              <a:t>28</a:t>
+              <a:t>27</a:t>
             </a:fld>
             <a:endParaRPr lang="fr-FR"/>
           </a:p>
@@ -1831,7 +1830,7 @@
           <a:p>
             <a:r>
               <a:rPr lang="fr-FR" dirty="0"/>
-              <a:t>Le nombre de textes associés à plusieurs catégories est donc seulement : 164 = 152 + 11 + 1</a:t>
+              <a:t>Le nombre de textes associés à plusieurs catégories est de seulement : 164 = 152 + 11 + 1</a:t>
             </a:r>
           </a:p>
           <a:p>
@@ -2909,7 +2908,7 @@
           <a:p>
             <a:fld id="{D61BD361-66C9-484E-B214-6DC7693ABA43}" type="datetimeFigureOut">
               <a:rPr lang="fr-FR" smtClean="0"/>
-              <a:t>25/08/2026</a:t>
+              <a:t>27/08/2026</a:t>
             </a:fld>
             <a:endParaRPr lang="fr-FR"/>
           </a:p>
@@ -3107,7 +3106,7 @@
           <a:p>
             <a:fld id="{D61BD361-66C9-484E-B214-6DC7693ABA43}" type="datetimeFigureOut">
               <a:rPr lang="fr-FR" smtClean="0"/>
-              <a:t>25/08/2026</a:t>
+              <a:t>27/08/2026</a:t>
             </a:fld>
             <a:endParaRPr lang="fr-FR"/>
           </a:p>
@@ -3315,7 +3314,7 @@
           <a:p>
             <a:fld id="{D61BD361-66C9-484E-B214-6DC7693ABA43}" type="datetimeFigureOut">
               <a:rPr lang="fr-FR" smtClean="0"/>
-              <a:t>25/08/2026</a:t>
+              <a:t>27/08/2026</a:t>
             </a:fld>
             <a:endParaRPr lang="fr-FR"/>
           </a:p>
@@ -3513,7 +3512,7 @@
           <a:p>
             <a:fld id="{D61BD361-66C9-484E-B214-6DC7693ABA43}" type="datetimeFigureOut">
               <a:rPr lang="fr-FR" smtClean="0"/>
-              <a:t>25/08/2026</a:t>
+              <a:t>27/08/2026</a:t>
             </a:fld>
             <a:endParaRPr lang="fr-FR"/>
           </a:p>
@@ -3788,7 +3787,7 @@
           <a:p>
             <a:fld id="{D61BD361-66C9-484E-B214-6DC7693ABA43}" type="datetimeFigureOut">
               <a:rPr lang="fr-FR" smtClean="0"/>
-              <a:t>25/08/2026</a:t>
+              <a:t>27/08/2026</a:t>
             </a:fld>
             <a:endParaRPr lang="fr-FR"/>
           </a:p>
@@ -4053,7 +4052,7 @@
           <a:p>
             <a:fld id="{D61BD361-66C9-484E-B214-6DC7693ABA43}" type="datetimeFigureOut">
               <a:rPr lang="fr-FR" smtClean="0"/>
-              <a:t>25/08/2026</a:t>
+              <a:t>27/08/2026</a:t>
             </a:fld>
             <a:endParaRPr lang="fr-FR"/>
           </a:p>
@@ -4465,7 +4464,7 @@
           <a:p>
             <a:fld id="{D61BD361-66C9-484E-B214-6DC7693ABA43}" type="datetimeFigureOut">
               <a:rPr lang="fr-FR" smtClean="0"/>
-              <a:t>25/08/2026</a:t>
+              <a:t>27/08/2026</a:t>
             </a:fld>
             <a:endParaRPr lang="fr-FR"/>
           </a:p>
@@ -4606,7 +4605,7 @@
           <a:p>
             <a:fld id="{D61BD361-66C9-484E-B214-6DC7693ABA43}" type="datetimeFigureOut">
               <a:rPr lang="fr-FR" smtClean="0"/>
-              <a:t>25/08/2026</a:t>
+              <a:t>27/08/2026</a:t>
             </a:fld>
             <a:endParaRPr lang="fr-FR"/>
           </a:p>
@@ -4719,7 +4718,7 @@
           <a:p>
             <a:fld id="{D61BD361-66C9-484E-B214-6DC7693ABA43}" type="datetimeFigureOut">
               <a:rPr lang="fr-FR" smtClean="0"/>
-              <a:t>25/08/2026</a:t>
+              <a:t>27/08/2026</a:t>
             </a:fld>
             <a:endParaRPr lang="fr-FR"/>
           </a:p>
@@ -5030,7 +5029,7 @@
           <a:p>
             <a:fld id="{D61BD361-66C9-484E-B214-6DC7693ABA43}" type="datetimeFigureOut">
               <a:rPr lang="fr-FR" smtClean="0"/>
-              <a:t>25/08/2026</a:t>
+              <a:t>27/08/2026</a:t>
             </a:fld>
             <a:endParaRPr lang="fr-FR"/>
           </a:p>
@@ -5318,7 +5317,7 @@
           <a:p>
             <a:fld id="{D61BD361-66C9-484E-B214-6DC7693ABA43}" type="datetimeFigureOut">
               <a:rPr lang="fr-FR" smtClean="0"/>
-              <a:t>25/08/2026</a:t>
+              <a:t>27/08/2026</a:t>
             </a:fld>
             <a:endParaRPr lang="fr-FR"/>
           </a:p>
@@ -5559,7 +5558,7 @@
           <a:p>
             <a:fld id="{D61BD361-66C9-484E-B214-6DC7693ABA43}" type="datetimeFigureOut">
               <a:rPr lang="fr-FR" smtClean="0"/>
-              <a:t>25/08/2026</a:t>
+              <a:t>27/08/2026</a:t>
             </a:fld>
             <a:endParaRPr lang="fr-FR"/>
           </a:p>
@@ -8528,7 +8527,7 @@
                   </a:schemeClr>
                 </a:solidFill>
               </a:rPr>
-              <a:t>Jeu d’entrainement filtré (~80,000 lignes)</a:t>
+              <a:t>Jeu d’entrainement filtré (~300,000 lignes)</a:t>
             </a:r>
           </a:p>
         </p:txBody>
@@ -9022,10 +9021,10 @@
       </p:grpSpPr>
       <p:pic>
         <p:nvPicPr>
-          <p:cNvPr id="12" name="Image 11">
+          <p:cNvPr id="3" name="Image 2">
             <a:extLst>
               <a:ext uri="{FF2B5EF4-FFF2-40B4-BE49-F238E27FC236}">
-                <a16:creationId xmlns:a16="http://schemas.microsoft.com/office/drawing/2014/main" id="{5C78883A-0889-A0F2-8521-815369DD8050}"/>
+                <a16:creationId xmlns:a16="http://schemas.microsoft.com/office/drawing/2014/main" id="{4A931B94-C1FB-9BE2-3281-36826804F21F}"/>
               </a:ext>
             </a:extLst>
           </p:cNvPr>
@@ -9042,8 +9041,8 @@
         </p:blipFill>
         <p:spPr>
           <a:xfrm>
-            <a:off x="510128" y="3116463"/>
-            <a:ext cx="11245845" cy="2608079"/>
+            <a:off x="534829" y="3286636"/>
+            <a:ext cx="11221144" cy="2409311"/>
           </a:xfrm>
           <a:prstGeom prst="rect">
             <a:avLst/>
@@ -9097,7 +9096,7 @@
         </p:nvSpPr>
         <p:spPr>
           <a:xfrm>
-            <a:off x="534829" y="5389152"/>
+            <a:off x="534829" y="5379102"/>
             <a:ext cx="11221144" cy="330200"/>
           </a:xfrm>
           <a:prstGeom prst="rect">
@@ -9243,10 +9242,10 @@
       </p:grpSpPr>
       <p:pic>
         <p:nvPicPr>
-          <p:cNvPr id="9" name="Image 8">
+          <p:cNvPr id="5" name="Image 4">
             <a:extLst>
               <a:ext uri="{FF2B5EF4-FFF2-40B4-BE49-F238E27FC236}">
-                <a16:creationId xmlns:a16="http://schemas.microsoft.com/office/drawing/2014/main" id="{ABC83A6F-F5AD-50A9-7C07-FEDF7E81C669}"/>
+                <a16:creationId xmlns:a16="http://schemas.microsoft.com/office/drawing/2014/main" id="{BD780736-8801-047C-7DC4-7DE42C1265A2}"/>
               </a:ext>
             </a:extLst>
           </p:cNvPr>
@@ -9263,8 +9262,8 @@
         </p:blipFill>
         <p:spPr>
           <a:xfrm>
-            <a:off x="871524" y="2118437"/>
-            <a:ext cx="10666019" cy="3695682"/>
+            <a:off x="689928" y="2150344"/>
+            <a:ext cx="10847615" cy="3659294"/>
           </a:xfrm>
           <a:prstGeom prst="rect">
             <a:avLst/>
@@ -9314,7 +9313,163 @@
         </p:nvSpPr>
         <p:spPr>
           <a:xfrm>
-            <a:off x="5220586" y="3904370"/>
+            <a:off x="5220586" y="3924466"/>
+            <a:ext cx="6316957" cy="272679"/>
+          </a:xfrm>
+          <a:prstGeom prst="rect">
+            <a:avLst/>
+          </a:prstGeom>
+          <a:noFill/>
+          <a:ln w="50800">
+            <a:solidFill>
+              <a:srgbClr val="FF0000"/>
+            </a:solidFill>
+          </a:ln>
+        </p:spPr>
+        <p:style>
+          <a:lnRef idx="2">
+            <a:schemeClr val="accent1">
+              <a:shade val="15000"/>
+            </a:schemeClr>
+          </a:lnRef>
+          <a:fillRef idx="1">
+            <a:schemeClr val="accent1"/>
+          </a:fillRef>
+          <a:effectRef idx="0">
+            <a:schemeClr val="accent1"/>
+          </a:effectRef>
+          <a:fontRef idx="minor">
+            <a:schemeClr val="lt1"/>
+          </a:fontRef>
+        </p:style>
+        <p:txBody>
+          <a:bodyPr rtlCol="0" anchor="ctr"/>
+          <a:lstStyle/>
+          <a:p>
+            <a:pPr algn="ctr"/>
+            <a:endParaRPr lang="fr-FR"/>
+          </a:p>
+        </p:txBody>
+      </p:sp>
+      <p:sp>
+        <p:nvSpPr>
+          <p:cNvPr id="3" name="Rectangle 2">
+            <a:extLst>
+              <a:ext uri="{FF2B5EF4-FFF2-40B4-BE49-F238E27FC236}">
+                <a16:creationId xmlns:a16="http://schemas.microsoft.com/office/drawing/2014/main" id="{4221B556-AA0A-275F-2A33-BD76597E0D63}"/>
+              </a:ext>
+            </a:extLst>
+          </p:cNvPr>
+          <p:cNvSpPr/>
+          <p:nvPr/>
+        </p:nvSpPr>
+        <p:spPr>
+          <a:xfrm>
+            <a:off x="3958523" y="4167001"/>
+            <a:ext cx="7579020" cy="272679"/>
+          </a:xfrm>
+          <a:prstGeom prst="rect">
+            <a:avLst/>
+          </a:prstGeom>
+          <a:noFill/>
+          <a:ln w="50800">
+            <a:solidFill>
+              <a:srgbClr val="FF0000"/>
+            </a:solidFill>
+          </a:ln>
+        </p:spPr>
+        <p:style>
+          <a:lnRef idx="2">
+            <a:schemeClr val="accent1">
+              <a:shade val="15000"/>
+            </a:schemeClr>
+          </a:lnRef>
+          <a:fillRef idx="1">
+            <a:schemeClr val="accent1"/>
+          </a:fillRef>
+          <a:effectRef idx="0">
+            <a:schemeClr val="accent1"/>
+          </a:effectRef>
+          <a:fontRef idx="minor">
+            <a:schemeClr val="lt1"/>
+          </a:fontRef>
+        </p:style>
+        <p:txBody>
+          <a:bodyPr rtlCol="0" anchor="ctr"/>
+          <a:lstStyle/>
+          <a:p>
+            <a:pPr algn="ctr"/>
+            <a:endParaRPr lang="fr-FR"/>
+          </a:p>
+        </p:txBody>
+      </p:sp>
+      <p:sp>
+        <p:nvSpPr>
+          <p:cNvPr id="6" name="Rectangle 5">
+            <a:extLst>
+              <a:ext uri="{FF2B5EF4-FFF2-40B4-BE49-F238E27FC236}">
+                <a16:creationId xmlns:a16="http://schemas.microsoft.com/office/drawing/2014/main" id="{58778992-C07D-2345-98DA-A9C15EACBD98}"/>
+              </a:ext>
+            </a:extLst>
+          </p:cNvPr>
+          <p:cNvSpPr/>
+          <p:nvPr/>
+        </p:nvSpPr>
+        <p:spPr>
+          <a:xfrm>
+            <a:off x="5220586" y="4616609"/>
+            <a:ext cx="6316957" cy="272679"/>
+          </a:xfrm>
+          <a:prstGeom prst="rect">
+            <a:avLst/>
+          </a:prstGeom>
+          <a:noFill/>
+          <a:ln w="50800">
+            <a:solidFill>
+              <a:srgbClr val="FF0000"/>
+            </a:solidFill>
+          </a:ln>
+        </p:spPr>
+        <p:style>
+          <a:lnRef idx="2">
+            <a:schemeClr val="accent1">
+              <a:shade val="15000"/>
+            </a:schemeClr>
+          </a:lnRef>
+          <a:fillRef idx="1">
+            <a:schemeClr val="accent1"/>
+          </a:fillRef>
+          <a:effectRef idx="0">
+            <a:schemeClr val="accent1"/>
+          </a:effectRef>
+          <a:fontRef idx="minor">
+            <a:schemeClr val="lt1"/>
+          </a:fontRef>
+        </p:style>
+        <p:txBody>
+          <a:bodyPr rtlCol="0" anchor="ctr"/>
+          <a:lstStyle/>
+          <a:p>
+            <a:pPr algn="ctr"/>
+            <a:endParaRPr lang="fr-FR"/>
+          </a:p>
+        </p:txBody>
+      </p:sp>
+      <p:sp>
+        <p:nvSpPr>
+          <p:cNvPr id="8" name="Rectangle 7">
+            <a:extLst>
+              <a:ext uri="{FF2B5EF4-FFF2-40B4-BE49-F238E27FC236}">
+                <a16:creationId xmlns:a16="http://schemas.microsoft.com/office/drawing/2014/main" id="{7933F423-DEB6-9128-EF17-CCCB4FE59618}"/>
+              </a:ext>
+            </a:extLst>
+          </p:cNvPr>
+          <p:cNvSpPr/>
+          <p:nvPr/>
+        </p:nvSpPr>
+        <p:spPr>
+          <a:xfrm>
+            <a:off x="5220586" y="3272564"/>
             <a:ext cx="6316957" cy="272679"/>
           </a:xfrm>
           <a:prstGeom prst="rect">
@@ -10979,7 +11134,7 @@
                   </a:schemeClr>
                 </a:solidFill>
               </a:rPr>
-              <a:t>Jeu d’entrainement filtré (~80,000 lignes)</a:t>
+              <a:t>Jeu d’entrainement filtré (~300,000 lignes)</a:t>
             </a:r>
           </a:p>
         </p:txBody>
@@ -11479,10 +11634,10 @@
       </p:grpSpPr>
       <p:pic>
         <p:nvPicPr>
-          <p:cNvPr id="4" name="Image 3">
+          <p:cNvPr id="10" name="Image 9">
             <a:extLst>
               <a:ext uri="{FF2B5EF4-FFF2-40B4-BE49-F238E27FC236}">
-                <a16:creationId xmlns:a16="http://schemas.microsoft.com/office/drawing/2014/main" id="{B205D234-2FD5-709D-D155-BAD05717D5F1}"/>
+                <a16:creationId xmlns:a16="http://schemas.microsoft.com/office/drawing/2014/main" id="{152356CF-B318-DB1A-C1C0-96749DB341E6}"/>
               </a:ext>
             </a:extLst>
           </p:cNvPr>
@@ -11499,8 +11654,8 @@
         </p:blipFill>
         <p:spPr>
           <a:xfrm>
-            <a:off x="647700" y="3147559"/>
-            <a:ext cx="11249990" cy="1549400"/>
+            <a:off x="647698" y="3153513"/>
+            <a:ext cx="11249991" cy="1458332"/>
           </a:xfrm>
           <a:prstGeom prst="rect">
             <a:avLst/>
@@ -11688,6 +11843,36 @@
           <a:chExt cx="0" cy="0"/>
         </a:xfrm>
       </p:grpSpPr>
+      <p:pic>
+        <p:nvPicPr>
+          <p:cNvPr id="10" name="Image 9">
+            <a:extLst>
+              <a:ext uri="{FF2B5EF4-FFF2-40B4-BE49-F238E27FC236}">
+                <a16:creationId xmlns:a16="http://schemas.microsoft.com/office/drawing/2014/main" id="{C97F0851-CA3A-FD32-89BC-A8D747A4D0D9}"/>
+              </a:ext>
+            </a:extLst>
+          </p:cNvPr>
+          <p:cNvPicPr>
+            <a:picLocks noChangeAspect="1"/>
+          </p:cNvPicPr>
+          <p:nvPr/>
+        </p:nvPicPr>
+        <p:blipFill>
+          <a:blip r:embed="rId3"/>
+          <a:stretch>
+            <a:fillRect/>
+          </a:stretch>
+        </p:blipFill>
+        <p:spPr>
+          <a:xfrm>
+            <a:off x="408275" y="2240196"/>
+            <a:ext cx="11371477" cy="3874076"/>
+          </a:xfrm>
+          <a:prstGeom prst="rect">
+            <a:avLst/>
+          </a:prstGeom>
+        </p:spPr>
+      </p:pic>
       <p:sp>
         <p:nvSpPr>
           <p:cNvPr id="2" name="Titre 1">
@@ -11717,36 +11902,6 @@
           </a:p>
         </p:txBody>
       </p:sp>
-      <p:pic>
-        <p:nvPicPr>
-          <p:cNvPr id="5" name="Image 4">
-            <a:extLst>
-              <a:ext uri="{FF2B5EF4-FFF2-40B4-BE49-F238E27FC236}">
-                <a16:creationId xmlns:a16="http://schemas.microsoft.com/office/drawing/2014/main" id="{ADB599FC-2416-F3A6-BD73-B56BD2785B0A}"/>
-              </a:ext>
-            </a:extLst>
-          </p:cNvPr>
-          <p:cNvPicPr>
-            <a:picLocks noChangeAspect="1"/>
-          </p:cNvPicPr>
-          <p:nvPr/>
-        </p:nvPicPr>
-        <p:blipFill>
-          <a:blip r:embed="rId3"/>
-          <a:stretch>
-            <a:fillRect/>
-          </a:stretch>
-        </p:blipFill>
-        <p:spPr>
-          <a:xfrm>
-            <a:off x="647699" y="2262188"/>
-            <a:ext cx="11091861" cy="3914775"/>
-          </a:xfrm>
-          <a:prstGeom prst="rect">
-            <a:avLst/>
-          </a:prstGeom>
-        </p:spPr>
-      </p:pic>
       <p:sp>
         <p:nvSpPr>
           <p:cNvPr id="3" name="Rectangle 2">
@@ -11763,6 +11918,110 @@
           <a:xfrm>
             <a:off x="5422603" y="4129199"/>
             <a:ext cx="6316957" cy="272679"/>
+          </a:xfrm>
+          <a:prstGeom prst="rect">
+            <a:avLst/>
+          </a:prstGeom>
+          <a:noFill/>
+          <a:ln w="50800">
+            <a:solidFill>
+              <a:srgbClr val="FF0000"/>
+            </a:solidFill>
+          </a:ln>
+        </p:spPr>
+        <p:style>
+          <a:lnRef idx="2">
+            <a:schemeClr val="accent1">
+              <a:shade val="15000"/>
+            </a:schemeClr>
+          </a:lnRef>
+          <a:fillRef idx="1">
+            <a:schemeClr val="accent1"/>
+          </a:fillRef>
+          <a:effectRef idx="0">
+            <a:schemeClr val="accent1"/>
+          </a:effectRef>
+          <a:fontRef idx="minor">
+            <a:schemeClr val="lt1"/>
+          </a:fontRef>
+        </p:style>
+        <p:txBody>
+          <a:bodyPr rtlCol="0" anchor="ctr"/>
+          <a:lstStyle/>
+          <a:p>
+            <a:pPr algn="ctr"/>
+            <a:endParaRPr lang="fr-FR"/>
+          </a:p>
+        </p:txBody>
+      </p:sp>
+      <p:sp>
+        <p:nvSpPr>
+          <p:cNvPr id="7" name="Rectangle 6">
+            <a:extLst>
+              <a:ext uri="{FF2B5EF4-FFF2-40B4-BE49-F238E27FC236}">
+                <a16:creationId xmlns:a16="http://schemas.microsoft.com/office/drawing/2014/main" id="{2019B489-7C8A-0548-F993-D87381E8A52E}"/>
+              </a:ext>
+            </a:extLst>
+          </p:cNvPr>
+          <p:cNvSpPr/>
+          <p:nvPr/>
+        </p:nvSpPr>
+        <p:spPr>
+          <a:xfrm>
+            <a:off x="5462795" y="4856976"/>
+            <a:ext cx="6316957" cy="272679"/>
+          </a:xfrm>
+          <a:prstGeom prst="rect">
+            <a:avLst/>
+          </a:prstGeom>
+          <a:noFill/>
+          <a:ln w="50800">
+            <a:solidFill>
+              <a:srgbClr val="FF0000"/>
+            </a:solidFill>
+          </a:ln>
+        </p:spPr>
+        <p:style>
+          <a:lnRef idx="2">
+            <a:schemeClr val="accent1">
+              <a:shade val="15000"/>
+            </a:schemeClr>
+          </a:lnRef>
+          <a:fillRef idx="1">
+            <a:schemeClr val="accent1"/>
+          </a:fillRef>
+          <a:effectRef idx="0">
+            <a:schemeClr val="accent1"/>
+          </a:effectRef>
+          <a:fontRef idx="minor">
+            <a:schemeClr val="lt1"/>
+          </a:fontRef>
+        </p:style>
+        <p:txBody>
+          <a:bodyPr rtlCol="0" anchor="ctr"/>
+          <a:lstStyle/>
+          <a:p>
+            <a:pPr algn="ctr"/>
+            <a:endParaRPr lang="fr-FR"/>
+          </a:p>
+        </p:txBody>
+      </p:sp>
+      <p:sp>
+        <p:nvSpPr>
+          <p:cNvPr id="8" name="Rectangle 7">
+            <a:extLst>
+              <a:ext uri="{FF2B5EF4-FFF2-40B4-BE49-F238E27FC236}">
+                <a16:creationId xmlns:a16="http://schemas.microsoft.com/office/drawing/2014/main" id="{6F9A7C73-A802-E626-1CCF-7AD01CC2E515}"/>
+              </a:ext>
+            </a:extLst>
+          </p:cNvPr>
+          <p:cNvSpPr/>
+          <p:nvPr/>
+        </p:nvSpPr>
+        <p:spPr>
+          <a:xfrm>
+            <a:off x="3786395" y="4401878"/>
+            <a:ext cx="7993357" cy="236794"/>
           </a:xfrm>
           <a:prstGeom prst="rect">
             <a:avLst/>
@@ -11905,71 +12164,6 @@
 </file>
 
 <file path=ppt/slides/slide20.xml><?xml version="1.0" encoding="utf-8"?>
-<p:sld xmlns:a="http://schemas.openxmlformats.org/drawingml/2006/main" xmlns:r="http://schemas.openxmlformats.org/officeDocument/2006/relationships" xmlns:p="http://schemas.openxmlformats.org/presentationml/2006/main">
-  <p:cSld>
-    <p:spTree>
-      <p:nvGrpSpPr>
-        <p:cNvPr id="1" name=""/>
-        <p:cNvGrpSpPr/>
-        <p:nvPr/>
-      </p:nvGrpSpPr>
-      <p:grpSpPr>
-        <a:xfrm>
-          <a:off x="0" y="0"/>
-          <a:ext cx="0" cy="0"/>
-          <a:chOff x="0" y="0"/>
-          <a:chExt cx="0" cy="0"/>
-        </a:xfrm>
-      </p:grpSpPr>
-      <p:pic>
-        <p:nvPicPr>
-          <p:cNvPr id="5" name="Espace réservé du contenu 4">
-            <a:extLst>
-              <a:ext uri="{FF2B5EF4-FFF2-40B4-BE49-F238E27FC236}">
-                <a16:creationId xmlns:a16="http://schemas.microsoft.com/office/drawing/2014/main" id="{3C04EB1A-7718-2E9C-C37B-EAF79173E90B}"/>
-              </a:ext>
-            </a:extLst>
-          </p:cNvPr>
-          <p:cNvPicPr>
-            <a:picLocks noGrp="1" noChangeAspect="1"/>
-          </p:cNvPicPr>
-          <p:nvPr>
-            <p:ph idx="1"/>
-          </p:nvPr>
-        </p:nvPicPr>
-        <p:blipFill>
-          <a:blip r:embed="rId2">
-            <a:extLst>
-              <a:ext uri="{28A0092B-C50C-407E-A947-70E740481C1C}">
-                <a14:useLocalDpi xmlns:a14="http://schemas.microsoft.com/office/drawing/2010/main" val="0"/>
-              </a:ext>
-            </a:extLst>
-          </a:blip>
-          <a:stretch>
-            <a:fillRect/>
-          </a:stretch>
-        </p:blipFill>
-        <p:spPr>
-          <a:xfrm>
-            <a:off x="4072270" y="142686"/>
-            <a:ext cx="7125665" cy="6572628"/>
-          </a:xfrm>
-        </p:spPr>
-      </p:pic>
-    </p:spTree>
-    <p:extLst>
-      <p:ext uri="{BB962C8B-B14F-4D97-AF65-F5344CB8AC3E}">
-        <p14:creationId xmlns:p14="http://schemas.microsoft.com/office/powerpoint/2010/main" val="2187063204"/>
-      </p:ext>
-    </p:extLst>
-  </p:cSld>
-  <p:clrMapOvr>
-    <a:masterClrMapping/>
-  </p:clrMapOvr>
-</p:sld>
-</file>
-
-<file path=ppt/slides/slide21.xml><?xml version="1.0" encoding="utf-8"?>
 <p:sld xmlns:a="http://schemas.openxmlformats.org/drawingml/2006/main" xmlns:r="http://schemas.openxmlformats.org/officeDocument/2006/relationships" xmlns:p="http://schemas.openxmlformats.org/presentationml/2006/main">
   <p:cSld>
     <p:spTree>
@@ -12135,7 +12329,7 @@
 </p:sld>
 </file>
 
-<file path=ppt/slides/slide22.xml><?xml version="1.0" encoding="utf-8"?>
+<file path=ppt/slides/slide21.xml><?xml version="1.0" encoding="utf-8"?>
 <p:sld xmlns:a="http://schemas.openxmlformats.org/drawingml/2006/main" xmlns:r="http://schemas.openxmlformats.org/officeDocument/2006/relationships" xmlns:p="http://schemas.openxmlformats.org/presentationml/2006/main">
   <p:cSld>
     <p:spTree>
@@ -12911,7 +13105,7 @@
 </p:sld>
 </file>
 
-<file path=ppt/slides/slide23.xml><?xml version="1.0" encoding="utf-8"?>
+<file path=ppt/slides/slide22.xml><?xml version="1.0" encoding="utf-8"?>
 <p:sld xmlns:a="http://schemas.openxmlformats.org/drawingml/2006/main" xmlns:r="http://schemas.openxmlformats.org/officeDocument/2006/relationships" xmlns:p="http://schemas.openxmlformats.org/presentationml/2006/main">
   <p:cSld>
     <p:spTree>
@@ -13077,7 +13271,7 @@
 </p:sld>
 </file>
 
-<file path=ppt/slides/slide24.xml><?xml version="1.0" encoding="utf-8"?>
+<file path=ppt/slides/slide23.xml><?xml version="1.0" encoding="utf-8"?>
 <p:sld xmlns:a="http://schemas.openxmlformats.org/drawingml/2006/main" xmlns:r="http://schemas.openxmlformats.org/officeDocument/2006/relationships" xmlns:p="http://schemas.openxmlformats.org/presentationml/2006/main">
   <p:cSld>
     <p:spTree>
@@ -13788,7 +13982,7 @@
 </p:sld>
 </file>
 
-<file path=ppt/slides/slide25.xml><?xml version="1.0" encoding="utf-8"?>
+<file path=ppt/slides/slide24.xml><?xml version="1.0" encoding="utf-8"?>
 <p:sld xmlns:a="http://schemas.openxmlformats.org/drawingml/2006/main" xmlns:r="http://schemas.openxmlformats.org/officeDocument/2006/relationships" xmlns:p="http://schemas.openxmlformats.org/presentationml/2006/main">
   <p:cSld>
     <p:spTree>
@@ -14604,7 +14798,7 @@
 </p:sld>
 </file>
 
-<file path=ppt/slides/slide26.xml><?xml version="1.0" encoding="utf-8"?>
+<file path=ppt/slides/slide25.xml><?xml version="1.0" encoding="utf-8"?>
 <p:sld xmlns:a="http://schemas.openxmlformats.org/drawingml/2006/main" xmlns:r="http://schemas.openxmlformats.org/officeDocument/2006/relationships" xmlns:p="http://schemas.openxmlformats.org/presentationml/2006/main">
   <p:cSld>
     <p:spTree>
@@ -14817,7 +15011,7 @@
 </p:sld>
 </file>
 
-<file path=ppt/slides/slide27.xml><?xml version="1.0" encoding="utf-8"?>
+<file path=ppt/slides/slide26.xml><?xml version="1.0" encoding="utf-8"?>
 <p:sld xmlns:a="http://schemas.openxmlformats.org/drawingml/2006/main" xmlns:r="http://schemas.openxmlformats.org/officeDocument/2006/relationships" xmlns:p="http://schemas.openxmlformats.org/presentationml/2006/main">
   <p:cSld>
     <p:spTree>
@@ -15466,7 +15660,7 @@
 </p:sld>
 </file>
 
-<file path=ppt/slides/slide28.xml><?xml version="1.0" encoding="utf-8"?>
+<file path=ppt/slides/slide27.xml><?xml version="1.0" encoding="utf-8"?>
 <p:sld xmlns:a="http://schemas.openxmlformats.org/drawingml/2006/main" xmlns:r="http://schemas.openxmlformats.org/officeDocument/2006/relationships" xmlns:p="http://schemas.openxmlformats.org/presentationml/2006/main">
   <p:cSld>
     <p:spTree>
@@ -15527,7 +15721,7 @@
             <p:ph idx="1"/>
             <p:extLst>
               <p:ext uri="{D42A27DB-BD31-4B8C-83A1-F6EECF244321}">
-                <p14:modId xmlns:p14="http://schemas.microsoft.com/office/powerpoint/2010/main" val="4281874336"/>
+                <p14:modId xmlns:p14="http://schemas.microsoft.com/office/powerpoint/2010/main" val="2286044339"/>
               </p:ext>
             </p:extLst>
           </p:nvPr>
@@ -15685,8 +15879,8 @@
                         <a:buNone/>
                       </a:pPr>
                       <a:r>
-                        <a:rPr lang="fr-FR" sz="1600" b="1"/>
-                        <a:t>Latence</a:t>
+                        <a:rPr lang="fr-FR" sz="1600" b="1" dirty="0"/>
+                        <a:t>Taux erreurs</a:t>
                       </a:r>
                     </a:p>
                   </a:txBody>
@@ -15701,9 +15895,18 @@
                         <a:buNone/>
                       </a:pPr>
                       <a:r>
-                        <a:rPr lang="fr-FR" sz="1600"/>
-                        <a:t>Très faible</a:t>
+                        <a:rPr lang="fr-FR" sz="1800" b="0" i="0" kern="1200" dirty="0">
+                          <a:solidFill>
+                            <a:schemeClr val="dk1"/>
+                          </a:solidFill>
+                          <a:effectLst/>
+                          <a:latin typeface="+mn-lt"/>
+                          <a:ea typeface="+mn-ea"/>
+                          <a:cs typeface="+mn-cs"/>
+                        </a:rPr>
+                        <a:t>15.04%</a:t>
                       </a:r>
+                      <a:endParaRPr lang="fr-FR" sz="1600" dirty="0"/>
                     </a:p>
                   </a:txBody>
                   <a:tcPr marL="77702" marR="77702" marT="38851" marB="38851" anchor="ctr"/>
@@ -15718,7 +15921,7 @@
                       </a:pPr>
                       <a:r>
                         <a:rPr lang="fr-FR" sz="1600" dirty="0"/>
-                        <a:t>Elevée</a:t>
+                        <a:t>XXXXXXXXXX</a:t>
                       </a:r>
                     </a:p>
                   </a:txBody>
@@ -15787,7 +15990,7 @@
                       </a:pPr>
                       <a:r>
                         <a:rPr lang="fr-FR" sz="1600" dirty="0"/>
-                        <a:t>~ 0,54 $ - (~4,58 $ medium)</a:t>
+                        <a:t>~ 0,54 $</a:t>
                       </a:r>
                     </a:p>
                   </a:txBody>
@@ -15847,7 +16050,7 @@
                       </a:pPr>
                       <a:r>
                         <a:rPr lang="fr-FR" sz="1600" dirty="0"/>
-                        <a:t>~ 1 000 requêtes / h - (650 / h medium)</a:t>
+                        <a:t>~ 1 000 requêtes / h</a:t>
                       </a:r>
                     </a:p>
                   </a:txBody>
@@ -16265,7 +16468,7 @@
 </p:sld>
 </file>
 
-<file path=ppt/slides/slide29.xml><?xml version="1.0" encoding="utf-8"?>
+<file path=ppt/slides/slide28.xml><?xml version="1.0" encoding="utf-8"?>
 <p:sld xmlns:a="http://schemas.openxmlformats.org/drawingml/2006/main" xmlns:r="http://schemas.openxmlformats.org/officeDocument/2006/relationships" xmlns:p="http://schemas.openxmlformats.org/presentationml/2006/main">
   <p:cSld>
     <p:spTree>
@@ -16303,7 +16506,10 @@
           <a:bodyPr/>
           <a:lstStyle/>
           <a:p>
-            <a:endParaRPr lang="fr-FR"/>
+            <a:r>
+              <a:rPr lang="fr-FR" dirty="0"/>
+              <a:t>En résumé</a:t>
+            </a:r>
           </a:p>
         </p:txBody>
       </p:sp>
@@ -16326,7 +16532,7 @@
         <p:spPr/>
         <p:txBody>
           <a:bodyPr>
-            <a:normAutofit fontScale="92500" lnSpcReduction="10000"/>
+            <a:normAutofit fontScale="85000" lnSpcReduction="20000"/>
           </a:bodyPr>
           <a:lstStyle/>
           <a:p>
@@ -16366,15 +16572,52 @@
           <a:p>
             <a:r>
               <a:rPr lang="fr-FR" dirty="0"/>
-              <a:t>Les performances varient fortement selon les catégories. Les catégories majoritaires et sémantiquement bien caractérisées sont correctement identifiées, tandis que les catégories minoritaires présentent un </a:t>
+              <a:t>Certains textes mal classés peuvent faire l’objet d’une interprétation différente. Le modèle peut apprendre « Consumer Loan » à partir d'exemples qui, selon le contenu, semblent relever de « </a:t>
             </a:r>
             <a:r>
               <a:rPr lang="fr-FR" dirty="0" err="1"/>
-              <a:t>recall</a:t>
+              <a:t>Vehicle</a:t>
             </a:r>
             <a:r>
               <a:rPr lang="fr-FR" dirty="0"/>
-              <a:t> plus faible.</a:t>
+              <a:t> </a:t>
+            </a:r>
+            <a:r>
+              <a:rPr lang="fr-FR" dirty="0" err="1"/>
+              <a:t>loan</a:t>
+            </a:r>
+            <a:r>
+              <a:rPr lang="fr-FR" dirty="0"/>
+              <a:t> or </a:t>
+            </a:r>
+            <a:r>
+              <a:rPr lang="fr-FR" dirty="0" err="1"/>
+              <a:t>lease</a:t>
+            </a:r>
+            <a:r>
+              <a:rPr lang="fr-FR" dirty="0"/>
+              <a:t> ».</a:t>
+            </a:r>
+          </a:p>
+          <a:p>
+            <a:endParaRPr lang="fr-FR" dirty="0"/>
+          </a:p>
+          <a:p>
+            <a:r>
+              <a:rPr lang="fr-FR" dirty="0" err="1"/>
+              <a:t>CalibratedClassifierCV</a:t>
+            </a:r>
+            <a:r>
+              <a:rPr lang="fr-FR" dirty="0"/>
+              <a:t> peut être utilisé comme base de </a:t>
+            </a:r>
+            <a:r>
+              <a:rPr lang="fr-FR" dirty="0" err="1"/>
+              <a:t>scoring</a:t>
+            </a:r>
+            <a:r>
+              <a:rPr lang="fr-FR" dirty="0"/>
+              <a:t> pour la confiance d’une prédiction. Si le score est trop bas, envisager une autre méthode de classification</a:t>
             </a:r>
           </a:p>
         </p:txBody>
@@ -16392,127 +16635,7 @@
 </p:sld>
 </file>
 
-<file path=ppt/slides/slide3.xml><?xml version="1.0" encoding="utf-8"?>
-<p:sld xmlns:a="http://schemas.openxmlformats.org/drawingml/2006/main" xmlns:r="http://schemas.openxmlformats.org/officeDocument/2006/relationships" xmlns:p="http://schemas.openxmlformats.org/presentationml/2006/main">
-  <p:cSld>
-    <p:spTree>
-      <p:nvGrpSpPr>
-        <p:cNvPr id="1" name=""/>
-        <p:cNvGrpSpPr/>
-        <p:nvPr/>
-      </p:nvGrpSpPr>
-      <p:grpSpPr>
-        <a:xfrm>
-          <a:off x="0" y="0"/>
-          <a:ext cx="0" cy="0"/>
-          <a:chOff x="0" y="0"/>
-          <a:chExt cx="0" cy="0"/>
-        </a:xfrm>
-      </p:grpSpPr>
-      <p:sp>
-        <p:nvSpPr>
-          <p:cNvPr id="2" name="Titre 1">
-            <a:extLst>
-              <a:ext uri="{FF2B5EF4-FFF2-40B4-BE49-F238E27FC236}">
-                <a16:creationId xmlns:a16="http://schemas.microsoft.com/office/drawing/2014/main" id="{CA0CB97F-097E-0FEC-42EB-89420D6043A1}"/>
-              </a:ext>
-            </a:extLst>
-          </p:cNvPr>
-          <p:cNvSpPr>
-            <a:spLocks noGrp="1"/>
-          </p:cNvSpPr>
-          <p:nvPr>
-            <p:ph type="title"/>
-          </p:nvPr>
-        </p:nvSpPr>
-        <p:spPr>
-          <a:xfrm>
-            <a:off x="838199" y="365125"/>
-            <a:ext cx="5360581" cy="3824103"/>
-          </a:xfrm>
-        </p:spPr>
-        <p:txBody>
-          <a:bodyPr>
-            <a:normAutofit/>
-          </a:bodyPr>
-          <a:lstStyle/>
-          <a:p>
-            <a:r>
-              <a:rPr lang="fr-FR" sz="6600" dirty="0">
-                <a:solidFill>
-                  <a:schemeClr val="accent1">
-                    <a:lumMod val="75000"/>
-                  </a:schemeClr>
-                </a:solidFill>
-                <a:latin typeface="Segoe UI Black" panose="020B0A02040204020203" pitchFamily="34" charset="0"/>
-                <a:ea typeface="Segoe UI Black" panose="020B0A02040204020203" pitchFamily="34" charset="0"/>
-              </a:rPr>
-              <a:t>Analyse exploratoire des données</a:t>
-            </a:r>
-          </a:p>
-        </p:txBody>
-      </p:sp>
-      <p:pic>
-        <p:nvPicPr>
-          <p:cNvPr id="2050" name="Picture 2" descr="Analyse exploratoire - Icônes ordinateur gratuites">
-            <a:extLst>
-              <a:ext uri="{FF2B5EF4-FFF2-40B4-BE49-F238E27FC236}">
-                <a16:creationId xmlns:a16="http://schemas.microsoft.com/office/drawing/2014/main" id="{AD618C70-2F2B-E7F8-3413-9BB4F19C3E28}"/>
-              </a:ext>
-            </a:extLst>
-          </p:cNvPr>
-          <p:cNvPicPr>
-            <a:picLocks noChangeAspect="1" noChangeArrowheads="1"/>
-          </p:cNvPicPr>
-          <p:nvPr/>
-        </p:nvPicPr>
-        <p:blipFill>
-          <a:blip r:embed="rId2">
-            <a:extLst>
-              <a:ext uri="{28A0092B-C50C-407E-A947-70E740481C1C}">
-                <a14:useLocalDpi xmlns:a14="http://schemas.microsoft.com/office/drawing/2010/main" val="0"/>
-              </a:ext>
-            </a:extLst>
-          </a:blip>
-          <a:srcRect/>
-          <a:stretch>
-            <a:fillRect/>
-          </a:stretch>
-        </p:blipFill>
-        <p:spPr bwMode="auto">
-          <a:xfrm>
-            <a:off x="6976731" y="1554126"/>
-            <a:ext cx="4876800" cy="4876800"/>
-          </a:xfrm>
-          <a:prstGeom prst="rect">
-            <a:avLst/>
-          </a:prstGeom>
-          <a:noFill/>
-          <a:extLst>
-            <a:ext uri="{909E8E84-426E-40DD-AFC4-6F175D3DCCD1}">
-              <a14:hiddenFill xmlns:a14="http://schemas.microsoft.com/office/drawing/2010/main">
-                <a:solidFill>
-                  <a:srgbClr val="FFFFFF"/>
-                </a:solidFill>
-              </a14:hiddenFill>
-            </a:ext>
-          </a:extLst>
-        </p:spPr>
-      </p:pic>
-    </p:spTree>
-    <p:extLst>
-      <p:ext uri="{BB962C8B-B14F-4D97-AF65-F5344CB8AC3E}">
-        <p14:creationId xmlns:p14="http://schemas.microsoft.com/office/powerpoint/2010/main" val="898818486"/>
-      </p:ext>
-    </p:extLst>
-  </p:cSld>
-  <p:clrMapOvr>
-    <a:masterClrMapping/>
-  </p:clrMapOvr>
-</p:sld>
-</file>
-
-<file path=ppt/slides/slide30.xml><?xml version="1.0" encoding="utf-8"?>
+<file path=ppt/slides/slide29.xml><?xml version="1.0" encoding="utf-8"?>
 <p:sld xmlns:a="http://schemas.openxmlformats.org/drawingml/2006/main" xmlns:r="http://schemas.openxmlformats.org/officeDocument/2006/relationships" xmlns:p="http://schemas.openxmlformats.org/presentationml/2006/main">
   <p:cSld>
     <p:spTree>
@@ -16580,6 +16703,126 @@
     <p:extLst>
       <p:ext uri="{BB962C8B-B14F-4D97-AF65-F5344CB8AC3E}">
         <p14:creationId xmlns:p14="http://schemas.microsoft.com/office/powerpoint/2010/main" val="988253673"/>
+      </p:ext>
+    </p:extLst>
+  </p:cSld>
+  <p:clrMapOvr>
+    <a:masterClrMapping/>
+  </p:clrMapOvr>
+</p:sld>
+</file>
+
+<file path=ppt/slides/slide3.xml><?xml version="1.0" encoding="utf-8"?>
+<p:sld xmlns:a="http://schemas.openxmlformats.org/drawingml/2006/main" xmlns:r="http://schemas.openxmlformats.org/officeDocument/2006/relationships" xmlns:p="http://schemas.openxmlformats.org/presentationml/2006/main">
+  <p:cSld>
+    <p:spTree>
+      <p:nvGrpSpPr>
+        <p:cNvPr id="1" name=""/>
+        <p:cNvGrpSpPr/>
+        <p:nvPr/>
+      </p:nvGrpSpPr>
+      <p:grpSpPr>
+        <a:xfrm>
+          <a:off x="0" y="0"/>
+          <a:ext cx="0" cy="0"/>
+          <a:chOff x="0" y="0"/>
+          <a:chExt cx="0" cy="0"/>
+        </a:xfrm>
+      </p:grpSpPr>
+      <p:sp>
+        <p:nvSpPr>
+          <p:cNvPr id="2" name="Titre 1">
+            <a:extLst>
+              <a:ext uri="{FF2B5EF4-FFF2-40B4-BE49-F238E27FC236}">
+                <a16:creationId xmlns:a16="http://schemas.microsoft.com/office/drawing/2014/main" id="{CA0CB97F-097E-0FEC-42EB-89420D6043A1}"/>
+              </a:ext>
+            </a:extLst>
+          </p:cNvPr>
+          <p:cNvSpPr>
+            <a:spLocks noGrp="1"/>
+          </p:cNvSpPr>
+          <p:nvPr>
+            <p:ph type="title"/>
+          </p:nvPr>
+        </p:nvSpPr>
+        <p:spPr>
+          <a:xfrm>
+            <a:off x="838199" y="365125"/>
+            <a:ext cx="5360581" cy="3824103"/>
+          </a:xfrm>
+        </p:spPr>
+        <p:txBody>
+          <a:bodyPr>
+            <a:normAutofit/>
+          </a:bodyPr>
+          <a:lstStyle/>
+          <a:p>
+            <a:r>
+              <a:rPr lang="fr-FR" sz="6600" dirty="0">
+                <a:solidFill>
+                  <a:schemeClr val="accent1">
+                    <a:lumMod val="75000"/>
+                  </a:schemeClr>
+                </a:solidFill>
+                <a:latin typeface="Segoe UI Black" panose="020B0A02040204020203" pitchFamily="34" charset="0"/>
+                <a:ea typeface="Segoe UI Black" panose="020B0A02040204020203" pitchFamily="34" charset="0"/>
+              </a:rPr>
+              <a:t>Analyse exploratoire des données</a:t>
+            </a:r>
+          </a:p>
+        </p:txBody>
+      </p:sp>
+      <p:pic>
+        <p:nvPicPr>
+          <p:cNvPr id="2050" name="Picture 2" descr="Analyse exploratoire - Icônes ordinateur gratuites">
+            <a:extLst>
+              <a:ext uri="{FF2B5EF4-FFF2-40B4-BE49-F238E27FC236}">
+                <a16:creationId xmlns:a16="http://schemas.microsoft.com/office/drawing/2014/main" id="{AD618C70-2F2B-E7F8-3413-9BB4F19C3E28}"/>
+              </a:ext>
+            </a:extLst>
+          </p:cNvPr>
+          <p:cNvPicPr>
+            <a:picLocks noChangeAspect="1" noChangeArrowheads="1"/>
+          </p:cNvPicPr>
+          <p:nvPr/>
+        </p:nvPicPr>
+        <p:blipFill>
+          <a:blip r:embed="rId2">
+            <a:extLst>
+              <a:ext uri="{28A0092B-C50C-407E-A947-70E740481C1C}">
+                <a14:useLocalDpi xmlns:a14="http://schemas.microsoft.com/office/drawing/2010/main" val="0"/>
+              </a:ext>
+            </a:extLst>
+          </a:blip>
+          <a:srcRect/>
+          <a:stretch>
+            <a:fillRect/>
+          </a:stretch>
+        </p:blipFill>
+        <p:spPr bwMode="auto">
+          <a:xfrm>
+            <a:off x="6976731" y="1554126"/>
+            <a:ext cx="4876800" cy="4876800"/>
+          </a:xfrm>
+          <a:prstGeom prst="rect">
+            <a:avLst/>
+          </a:prstGeom>
+          <a:noFill/>
+          <a:extLst>
+            <a:ext uri="{909E8E84-426E-40DD-AFC4-6F175D3DCCD1}">
+              <a14:hiddenFill xmlns:a14="http://schemas.microsoft.com/office/drawing/2010/main">
+                <a:solidFill>
+                  <a:srgbClr val="FFFFFF"/>
+                </a:solidFill>
+              </a14:hiddenFill>
+            </a:ext>
+          </a:extLst>
+        </p:spPr>
+      </p:pic>
+    </p:spTree>
+    <p:extLst>
+      <p:ext uri="{BB962C8B-B14F-4D97-AF65-F5344CB8AC3E}">
+        <p14:creationId xmlns:p14="http://schemas.microsoft.com/office/powerpoint/2010/main" val="898818486"/>
       </p:ext>
     </p:extLst>
   </p:cSld>
@@ -16642,7 +16885,7 @@
           <a:p>
             <a:r>
               <a:rPr lang="fr-FR" dirty="0"/>
-              <a:t>Valeurs manquantes dans la variable </a:t>
+              <a:t>70% Valeurs manquantes dans la variable </a:t>
             </a:r>
             <a:r>
               <a:rPr lang="fr-FR" i="1" dirty="0">
@@ -16696,13 +16939,7 @@
           <a:p>
             <a:r>
               <a:rPr lang="fr-FR" dirty="0"/>
-              <a:t>Les valeurs manquantes semblent donc potentiellement structurelles plutôt qu'aléatoires</a:t>
-            </a:r>
-          </a:p>
-          <a:p>
-            <a:r>
-              <a:rPr lang="fr-FR" dirty="0"/>
-              <a:t>70% des valeurs sont manquantes</a:t>
+              <a:t>Les valeurs manquantes semblent structurelles plutôt qu'aléatoires</a:t>
             </a:r>
           </a:p>
           <a:p>
@@ -16863,6 +17100,12 @@
             <a:normAutofit/>
           </a:bodyPr>
           <a:lstStyle/>
+          <a:p>
+            <a:r>
+              <a:rPr lang="fr-FR" dirty="0"/>
+              <a:t>Ambiguïté dans la nomenclature des classes</a:t>
+            </a:r>
+          </a:p>
           <a:p>
             <a:r>
               <a:rPr lang="fr-FR" dirty="0"/>
@@ -18920,7 +19163,7 @@
                         <a:buNone/>
                       </a:pPr>
                       <a:r>
-                        <a:rPr lang="fr-FR" sz="1800" b="0" u="none" strike="noStrike">
+                        <a:rPr lang="fr-FR" sz="1800" b="0" u="none" strike="noStrike" dirty="0">
                           <a:solidFill>
                             <a:schemeClr val="bg1"/>
                           </a:solidFill>
@@ -18928,7 +19171,7 @@
                         </a:rPr>
                         <a:t>quelle est la répartition des catégories ?</a:t>
                       </a:r>
-                      <a:endParaRPr lang="fr-FR" sz="1800" b="0" i="0" u="none" strike="noStrike">
+                      <a:endParaRPr lang="fr-FR" sz="1800" b="0" i="0" u="none" strike="noStrike" dirty="0">
                         <a:solidFill>
                           <a:schemeClr val="bg1"/>
                         </a:solidFill>
@@ -19049,7 +19292,7 @@
                         <a:buNone/>
                       </a:pPr>
                       <a:r>
-                        <a:rPr lang="fr-FR" sz="1800" b="0" u="none" strike="noStrike">
+                        <a:rPr lang="fr-FR" sz="1800" b="0" u="none" strike="noStrike" dirty="0">
                           <a:solidFill>
                             <a:schemeClr val="bg1"/>
                           </a:solidFill>
@@ -19057,7 +19300,7 @@
                         </a:rPr>
                         <a:t>quelle proportion de Consumer Claim est manquante ?</a:t>
                       </a:r>
-                      <a:endParaRPr lang="fr-FR" sz="1800" b="0" i="0" u="none" strike="noStrike">
+                      <a:endParaRPr lang="fr-FR" sz="1800" b="0" i="0" u="none" strike="noStrike" dirty="0">
                         <a:solidFill>
                           <a:schemeClr val="bg1"/>
                         </a:solidFill>
@@ -19178,15 +19421,33 @@
                         <a:buNone/>
                       </a:pPr>
                       <a:r>
-                        <a:rPr lang="fr-FR" sz="1800" b="0" u="none" strike="noStrike">
+                        <a:rPr lang="fr-FR" sz="1800" b="0" u="none" strike="noStrike" dirty="0">
                           <a:solidFill>
                             <a:schemeClr val="bg1"/>
                           </a:solidFill>
                           <a:effectLst/>
                         </a:rPr>
-                        <a:t>les valeurs manquantes dépendent-elles de Submitted via ?</a:t>
+                        <a:t>les valeurs manquantes dépendent-elles de </a:t>
                       </a:r>
-                      <a:endParaRPr lang="fr-FR" sz="1800" b="0" i="0" u="none" strike="noStrike">
+                      <a:r>
+                        <a:rPr lang="fr-FR" sz="1800" b="0" u="none" strike="noStrike" dirty="0" err="1">
+                          <a:solidFill>
+                            <a:schemeClr val="bg1"/>
+                          </a:solidFill>
+                          <a:effectLst/>
+                        </a:rPr>
+                        <a:t>Submitted</a:t>
+                      </a:r>
+                      <a:r>
+                        <a:rPr lang="fr-FR" sz="1800" b="0" u="none" strike="noStrike" dirty="0">
+                          <a:solidFill>
+                            <a:schemeClr val="bg1"/>
+                          </a:solidFill>
+                          <a:effectLst/>
+                        </a:rPr>
+                        <a:t> via ?</a:t>
+                      </a:r>
+                      <a:endParaRPr lang="fr-FR" sz="1800" b="0" i="0" u="none" strike="noStrike" dirty="0">
                         <a:solidFill>
                           <a:schemeClr val="bg1"/>
                         </a:solidFill>
@@ -19551,7 +19812,7 @@
                         <a:buNone/>
                       </a:pPr>
                       <a:r>
-                        <a:rPr lang="fr-FR" sz="1800" b="0" u="none" strike="noStrike">
+                        <a:rPr lang="fr-FR" sz="1800" b="0" u="none" strike="noStrike" dirty="0">
                           <a:solidFill>
                             <a:schemeClr val="bg1"/>
                           </a:solidFill>
@@ -19559,7 +19820,7 @@
                         </a:rPr>
                         <a:t>Une réclamation renseignée contient en moyenne environ 1 082 caractères.</a:t>
                       </a:r>
-                      <a:endParaRPr lang="fr-FR" sz="1800" b="0" i="0" u="none" strike="noStrike">
+                      <a:endParaRPr lang="fr-FR" sz="1800" b="0" i="0" u="none" strike="noStrike" dirty="0">
                         <a:solidFill>
                           <a:schemeClr val="bg1"/>
                         </a:solidFill>

</xml_diff>